<commit_message>
adding muddy point shells
</commit_message>
<xml_diff>
--- a/docs/lessons/17_Missing_data/17_Activity_dogs.pptx
+++ b/docs/lessons/17_Missing_data/17_Activity_dogs.pptx
@@ -129,6 +129,50 @@
 </p1510:revInfo>
 </file>
 
+<file path=ppt/changesInfos/changesInfo1.xml><?xml version="1.0" encoding="utf-8"?>
+<pc:chgInfo xmlns:a="http://schemas.openxmlformats.org/drawingml/2006/main" xmlns:r="http://schemas.openxmlformats.org/officeDocument/2006/relationships" xmlns:ac="http://schemas.microsoft.com/office/drawing/2013/main/command" xmlns:pc="http://schemas.microsoft.com/office/powerpoint/2013/main/command">
+  <pc:docChgLst>
+    <pc:chgData name="Nicky Wakim" userId="63a62853-8dd4-431b-8872-ecc2181a70d8" providerId="ADAL" clId="{E3D25C46-8FD1-A44F-85DA-38FB5F4E25B5}"/>
+    <pc:docChg chg="modSld">
+      <pc:chgData name="Nicky Wakim" userId="63a62853-8dd4-431b-8872-ecc2181a70d8" providerId="ADAL" clId="{E3D25C46-8FD1-A44F-85DA-38FB5F4E25B5}" dt="2025-06-02T21:21:39.711" v="6" actId="20577"/>
+      <pc:docMkLst>
+        <pc:docMk/>
+      </pc:docMkLst>
+      <pc:sldChg chg="modSp mod">
+        <pc:chgData name="Nicky Wakim" userId="63a62853-8dd4-431b-8872-ecc2181a70d8" providerId="ADAL" clId="{E3D25C46-8FD1-A44F-85DA-38FB5F4E25B5}" dt="2025-06-02T21:15:53.392" v="1" actId="1076"/>
+        <pc:sldMkLst>
+          <pc:docMk/>
+          <pc:sldMk cId="2105346721" sldId="257"/>
+        </pc:sldMkLst>
+        <pc:spChg chg="mod">
+          <ac:chgData name="Nicky Wakim" userId="63a62853-8dd4-431b-8872-ecc2181a70d8" providerId="ADAL" clId="{E3D25C46-8FD1-A44F-85DA-38FB5F4E25B5}" dt="2025-06-02T21:15:53.392" v="1" actId="1076"/>
+          <ac:spMkLst>
+            <pc:docMk/>
+            <pc:sldMk cId="2105346721" sldId="257"/>
+            <ac:spMk id="16" creationId="{0CD43DB0-92BA-13DE-673B-4B75E5085D1A}"/>
+          </ac:spMkLst>
+        </pc:spChg>
+      </pc:sldChg>
+      <pc:sldChg chg="modSp mod">
+        <pc:chgData name="Nicky Wakim" userId="63a62853-8dd4-431b-8872-ecc2181a70d8" providerId="ADAL" clId="{E3D25C46-8FD1-A44F-85DA-38FB5F4E25B5}" dt="2025-06-02T21:21:39.711" v="6" actId="20577"/>
+        <pc:sldMkLst>
+          <pc:docMk/>
+          <pc:sldMk cId="2847282807" sldId="260"/>
+        </pc:sldMkLst>
+        <pc:spChg chg="mod">
+          <ac:chgData name="Nicky Wakim" userId="63a62853-8dd4-431b-8872-ecc2181a70d8" providerId="ADAL" clId="{E3D25C46-8FD1-A44F-85DA-38FB5F4E25B5}" dt="2025-06-02T21:21:39.711" v="6" actId="20577"/>
+          <ac:spMkLst>
+            <pc:docMk/>
+            <pc:sldMk cId="2847282807" sldId="260"/>
+            <ac:spMk id="3" creationId="{18F3951D-11FA-3C10-B269-93013B012360}"/>
+          </ac:spMkLst>
+        </pc:spChg>
+      </pc:sldChg>
+    </pc:docChg>
+  </pc:docChgLst>
+</pc:chgInfo>
+</file>
+
 <file path=ppt/notesMasters/notesMaster1.xml><?xml version="1.0" encoding="utf-8"?>
 <p:notesMaster xmlns:a="http://schemas.openxmlformats.org/drawingml/2006/main" xmlns:r="http://schemas.openxmlformats.org/officeDocument/2006/relationships" xmlns:p="http://schemas.openxmlformats.org/presentationml/2006/main">
   <p:cSld>
@@ -211,7 +255,7 @@
           <a:p>
             <a:fld id="{114978BC-B06D-E54B-9425-EAE9C145D3AE}" type="datetimeFigureOut">
               <a:rPr lang="en-US" smtClean="0"/>
-              <a:t>6/1/25</a:t>
+              <a:t>6/2/25</a:t>
             </a:fld>
             <a:endParaRPr lang="en-US"/>
           </a:p>
@@ -801,7 +845,7 @@
           <a:p>
             <a:fld id="{BCC16B26-9395-B44B-9BD0-B3EFFDF164FD}" type="datetimeFigureOut">
               <a:rPr lang="en-US" smtClean="0"/>
-              <a:t>6/1/25</a:t>
+              <a:t>6/2/25</a:t>
             </a:fld>
             <a:endParaRPr lang="en-US"/>
           </a:p>
@@ -1076,7 +1120,7 @@
           <a:p>
             <a:fld id="{BCC16B26-9395-B44B-9BD0-B3EFFDF164FD}" type="datetimeFigureOut">
               <a:rPr lang="en-US" smtClean="0"/>
-              <a:t>6/1/25</a:t>
+              <a:t>6/2/25</a:t>
             </a:fld>
             <a:endParaRPr lang="en-US"/>
           </a:p>
@@ -1246,7 +1290,7 @@
           <a:p>
             <a:fld id="{BCC16B26-9395-B44B-9BD0-B3EFFDF164FD}" type="datetimeFigureOut">
               <a:rPr lang="en-US" smtClean="0"/>
-              <a:t>6/1/25</a:t>
+              <a:t>6/2/25</a:t>
             </a:fld>
             <a:endParaRPr lang="en-US"/>
           </a:p>
@@ -1426,7 +1470,7 @@
           <a:p>
             <a:fld id="{BCC16B26-9395-B44B-9BD0-B3EFFDF164FD}" type="datetimeFigureOut">
               <a:rPr lang="en-US" smtClean="0"/>
-              <a:t>6/1/25</a:t>
+              <a:t>6/2/25</a:t>
             </a:fld>
             <a:endParaRPr lang="en-US"/>
           </a:p>
@@ -1596,7 +1640,7 @@
           <a:p>
             <a:fld id="{BCC16B26-9395-B44B-9BD0-B3EFFDF164FD}" type="datetimeFigureOut">
               <a:rPr lang="en-US" smtClean="0"/>
-              <a:t>6/1/25</a:t>
+              <a:t>6/2/25</a:t>
             </a:fld>
             <a:endParaRPr lang="en-US"/>
           </a:p>
@@ -1719,7 +1763,7 @@
           <a:p>
             <a:fld id="{BCC16B26-9395-B44B-9BD0-B3EFFDF164FD}" type="datetimeFigureOut">
               <a:rPr lang="en-US" smtClean="0"/>
-              <a:t>6/1/25</a:t>
+              <a:t>6/2/25</a:t>
             </a:fld>
             <a:endParaRPr lang="en-US"/>
           </a:p>
@@ -1933,7 +1977,7 @@
           <a:p>
             <a:fld id="{BCC16B26-9395-B44B-9BD0-B3EFFDF164FD}" type="datetimeFigureOut">
               <a:rPr lang="en-US" smtClean="0"/>
-              <a:t>6/1/25</a:t>
+              <a:t>6/2/25</a:t>
             </a:fld>
             <a:endParaRPr lang="en-US"/>
           </a:p>
@@ -2147,7 +2191,7 @@
           <a:p>
             <a:fld id="{BCC16B26-9395-B44B-9BD0-B3EFFDF164FD}" type="datetimeFigureOut">
               <a:rPr lang="en-US" smtClean="0"/>
-              <a:t>6/1/25</a:t>
+              <a:t>6/2/25</a:t>
             </a:fld>
             <a:endParaRPr lang="en-US"/>
           </a:p>
@@ -2378,7 +2422,7 @@
           <a:p>
             <a:fld id="{BCC16B26-9395-B44B-9BD0-B3EFFDF164FD}" type="datetimeFigureOut">
               <a:rPr lang="en-US" smtClean="0"/>
-              <a:t>6/1/25</a:t>
+              <a:t>6/2/25</a:t>
             </a:fld>
             <a:endParaRPr lang="en-US"/>
           </a:p>
@@ -2729,7 +2773,7 @@
           <a:p>
             <a:fld id="{BCC16B26-9395-B44B-9BD0-B3EFFDF164FD}" type="datetimeFigureOut">
               <a:rPr lang="en-US" smtClean="0"/>
-              <a:t>6/1/25</a:t>
+              <a:t>6/2/25</a:t>
             </a:fld>
             <a:endParaRPr lang="en-US"/>
           </a:p>
@@ -2961,7 +3005,7 @@
           <a:p>
             <a:fld id="{BCC16B26-9395-B44B-9BD0-B3EFFDF164FD}" type="datetimeFigureOut">
               <a:rPr lang="en-US" smtClean="0"/>
-              <a:t>6/1/25</a:t>
+              <a:t>6/2/25</a:t>
             </a:fld>
             <a:endParaRPr lang="en-US"/>
           </a:p>
@@ -3328,7 +3372,7 @@
           <a:p>
             <a:fld id="{BCC16B26-9395-B44B-9BD0-B3EFFDF164FD}" type="datetimeFigureOut">
               <a:rPr lang="en-US" smtClean="0"/>
-              <a:t>6/1/25</a:t>
+              <a:t>6/2/25</a:t>
             </a:fld>
             <a:endParaRPr lang="en-US"/>
           </a:p>
@@ -3446,7 +3490,7 @@
           <a:p>
             <a:fld id="{BCC16B26-9395-B44B-9BD0-B3EFFDF164FD}" type="datetimeFigureOut">
               <a:rPr lang="en-US" smtClean="0"/>
-              <a:t>6/1/25</a:t>
+              <a:t>6/2/25</a:t>
             </a:fld>
             <a:endParaRPr lang="en-US"/>
           </a:p>
@@ -3541,7 +3585,7 @@
           <a:p>
             <a:fld id="{BCC16B26-9395-B44B-9BD0-B3EFFDF164FD}" type="datetimeFigureOut">
               <a:rPr lang="en-US" smtClean="0"/>
-              <a:t>6/1/25</a:t>
+              <a:t>6/2/25</a:t>
             </a:fld>
             <a:endParaRPr lang="en-US"/>
           </a:p>
@@ -3818,7 +3862,7 @@
           <a:p>
             <a:fld id="{BCC16B26-9395-B44B-9BD0-B3EFFDF164FD}" type="datetimeFigureOut">
               <a:rPr lang="en-US" smtClean="0"/>
-              <a:t>6/1/25</a:t>
+              <a:t>6/2/25</a:t>
             </a:fld>
             <a:endParaRPr lang="en-US"/>
           </a:p>
@@ -4031,7 +4075,7 @@
           <a:p>
             <a:fld id="{BCC16B26-9395-B44B-9BD0-B3EFFDF164FD}" type="datetimeFigureOut">
               <a:rPr lang="en-US" smtClean="0"/>
-              <a:t>6/1/25</a:t>
+              <a:t>6/2/25</a:t>
             </a:fld>
             <a:endParaRPr lang="en-US"/>
           </a:p>
@@ -4970,7 +5014,7 @@
         </p:nvSpPr>
         <p:spPr>
           <a:xfrm>
-            <a:off x="9211149" y="4775226"/>
+            <a:off x="8980372" y="3552423"/>
             <a:ext cx="933649" cy="1073885"/>
           </a:xfrm>
           <a:prstGeom prst="rect">
@@ -5328,7 +5372,7 @@
           <a:p>
             <a:r>
               <a:rPr lang="en-US" dirty="0"/>
-              <a:t>How would you approach this data?</a:t>
+              <a:t>How would you approach these data?</a:t>
             </a:r>
           </a:p>
         </p:txBody>

</xml_diff>